<commit_message>
fix: align UI with folder metadata, issues API and scan errors
</commit_message>
<xml_diff>
--- a/docs/CoreSpace-Theeramet.pptx
+++ b/docs/CoreSpace-Theeramet.pptx
@@ -2,19 +2,19 @@
 <file path=ppt/presentation.xml><?xml version="1.0" encoding="utf-8"?>
 <p:presentation xmlns:p="http://schemas.openxmlformats.org/presentationml/2006/main">
   <p:sldMasterIdLst>
-    <p:sldMasterId xmlns:r="http://schemas.openxmlformats.org/officeDocument/2006/relationships" id="2147483648" r:id="R6b1d98c4425b47f7"/>
+    <p:sldMasterId xmlns:r="http://schemas.openxmlformats.org/officeDocument/2006/relationships" id="2147483648" r:id="Re2521e027bb84be0"/>
   </p:sldMasterIdLst>
   <p:notesMasterIdLst>
-    <p:notesMasterId xmlns:r="http://schemas.openxmlformats.org/officeDocument/2006/relationships" r:id="Rd87dd40eade34005"/>
+    <p:notesMasterId xmlns:r="http://schemas.openxmlformats.org/officeDocument/2006/relationships" r:id="Re4ac29cf83b848a7"/>
   </p:notesMasterIdLst>
   <p:sldIdLst>
-    <p:sldId xmlns:r="http://schemas.openxmlformats.org/officeDocument/2006/relationships" id="256" r:id="Rc996954f15984fb9"/>
-    <p:sldId xmlns:r="http://schemas.openxmlformats.org/officeDocument/2006/relationships" id="257" r:id="R1f04ca80d4554f62"/>
-    <p:sldId xmlns:r="http://schemas.openxmlformats.org/officeDocument/2006/relationships" id="258" r:id="Rdb03a3c590f1453c"/>
-    <p:sldId xmlns:r="http://schemas.openxmlformats.org/officeDocument/2006/relationships" id="259" r:id="R470995edbea0499d"/>
-    <p:sldId xmlns:r="http://schemas.openxmlformats.org/officeDocument/2006/relationships" id="260" r:id="Rc44d59514d574b87"/>
-    <p:sldId xmlns:r="http://schemas.openxmlformats.org/officeDocument/2006/relationships" id="261" r:id="R54f40c08f26f4c15"/>
-    <p:sldId xmlns:r="http://schemas.openxmlformats.org/officeDocument/2006/relationships" id="262" r:id="R40a356b48f574cfe"/>
+    <p:sldId xmlns:r="http://schemas.openxmlformats.org/officeDocument/2006/relationships" id="256" r:id="Rd721f0fe8ce2456f"/>
+    <p:sldId xmlns:r="http://schemas.openxmlformats.org/officeDocument/2006/relationships" id="257" r:id="R028616e483664481"/>
+    <p:sldId xmlns:r="http://schemas.openxmlformats.org/officeDocument/2006/relationships" id="258" r:id="Rac607d536e644639"/>
+    <p:sldId xmlns:r="http://schemas.openxmlformats.org/officeDocument/2006/relationships" id="259" r:id="R543154fc5f2a4ddc"/>
+    <p:sldId xmlns:r="http://schemas.openxmlformats.org/officeDocument/2006/relationships" id="260" r:id="R517112c6e5b5412c"/>
+    <p:sldId xmlns:r="http://schemas.openxmlformats.org/officeDocument/2006/relationships" id="261" r:id="Ra95a976e0eca41bd"/>
+    <p:sldId xmlns:r="http://schemas.openxmlformats.org/officeDocument/2006/relationships" id="262" r:id="R871543ee694647d0"/>
   </p:sldIdLst>
   <p:sldSz cx="12192000" cy="6858000"/>
   <p:notesSz cx="6858000" cy="9144000"/>
@@ -448,7 +448,7 @@
           <a:lstStyle xmlns:a="http://schemas.openxmlformats.org/drawingml/2006/main"/>
           <a:p xmlns:a="http://schemas.openxmlformats.org/drawingml/2006/main">
             <a:r>
-              <a:t>เริ่มว่า เราต้องการรู้ว่าโฟลเดอร์ไหนใช้พื้นที่มาก จึงทำเว็บให้เลือกโฟลเดอร์ ดูรายการและขนาดได้ งานแบ่งเป็นศรัณย์ทำ C, ปวริศช์ทำ Python bridge และธีรเมธทำ UI ภาพประกอบนี้เป็นภาพรัน UI จริงกับ simulator ไม่ใช่ผลสแกนจาก C/WSL วันนำเสนอ 9 ตุลาคม 2569 เวลา 13:00 น. สถานะเอกสาร ณ 4 ตุลาคม 2569</a:t>
+              <a:t>เริ่มว่า เราต้องการรู้ว่าโฟลเดอร์ไหนใช้พื้นที่มาก จึงทำเว็บให้เลือกโฟลเดอร์ ดูรายการและขนาดได้ งานแบ่งเป็นศรัณย์ทำ C, ปวริศช์ทำ Python bridge และธีรเมธทำ UI ภาพประกอบนี้เป็นภาพรัน UI จริงกับ simulator ไม่ใช่ผลสแกนจาก C/WSL วันนำเสนอ 9 ตุลาคม 2569 เวลา 13:00 น. สถานะเอกสาร ณ 5 ตุลาคม 2569</a:t>
             </a:r>
           </a:p>
         </p:txBody>
@@ -593,7 +593,7 @@
           <a:lstStyle xmlns:a="http://schemas.openxmlformats.org/drawingml/2006/main"/>
           <a:p xmlns:a="http://schemas.openxmlformats.org/drawingml/2006/main">
             <a:r>
-              <a:t>นี่คือสถาปัตยกรรมเป้าหมายตาม CONTRACT ไม่ใช่คำรับรองว่า backend รุ่นนี้ทำครบ POST /api/scans คืน id ก่อน scan จบ จากนั้นหน้าเว็บขอ GET /api/scans/{id} และ children Python ต้องแปลง path จาก D:\demo เป็น /mnt/d/demo ตรวจ relativePath และแยก stderr จาก stdout JSON เป็นรูปแบบข้อมูล HTTP กับ pipe เป็นช่องทางสื่อสาร</a:t>
+              <a:t>Python bridge และ SQLite รวมใน checkout แล้ว ทดสอบ Browser → Python → SQLite ด้วยข้อมูลทดสอบ ส่วน C/WSL และ Windows ต้องยืนยันบนเครื่องนำเสนอ POST /api/scans คืน id ก่อน scan จบ จากนั้นหน้าเว็บขอ GET /api/scans/{id} และ children Python ต้องแปลง path จาก D:\demo เป็น /mnt/d/demo ตรวจ relativePath และแยก stderr จาก stdout JSON เป็นรูปแบบข้อมูล HTTP กับ pipe เป็นช่องทางสื่อสาร</a:t>
             </a:r>
           </a:p>
           <a:p xmlns:a="http://schemas.openxmlformats.org/drawingml/2006/main">
@@ -668,7 +668,7 @@
           <a:lstStyle xmlns:a="http://schemas.openxmlformats.org/drawingml/2006/main"/>
           <a:p xmlns:a="http://schemas.openxmlformats.org/drawingml/2006/main">
             <a:r>
-              <a:t>ไม่ใช้สูตรปัด cluster แทนค่าที่วัด และไม่เรียก Allocated ลบ Logical ว่า Slack เสมอ UI แสดงค่าจาก backend โฟลเดอร์ต้องรวมจากผลทั้งโฟลเดอร์ ไม่ใช่แค่ 50 แถวบนจอ CONTRACT ยังไม่ระบุ root totals จึงแสดงไม่ทราบแทนการเดา ตอนนำเสนอให้ปวริศช์แสดงไฟล์ที่ตรวจเทียบ Windows จริงหนึ่งไฟล์ ปัจจุบันยังไม่มีหลักฐานนั้นในชุดส่งนี้</a:t>
+              <a:t>ไม่ใช้สูตรปัด cluster แทนค่าที่วัด และไม่เรียก Allocated ลบ Logical ว่า Slack เสมอ UI แสดงค่าจาก backend โฟลเดอร์ต้องรวมจากผลทั้งโฟลเดอร์ ไม่ใช่แค่ 50 แถวบนจอ ยอด root และโฟลเดอร์ที่เลือกอ่านจาก children.folder ตาม API ล่าสุด หลังสแกนจบจะโหลด metadata ใหม่ ค่า 0 แสดง 0 B ส่วน null แสดงไม่ทราบ ตอนนำเสนอให้ปวริศช์แสดงไฟล์ที่ตรวจเทียบ Windows จริงหนึ่งไฟล์ ปัจจุบันยังไม่มีหลักฐานนั้นในชุดส่งนี้</a:t>
             </a:r>
           </a:p>
           <a:p xmlns:a="http://schemas.openxmlformats.org/drawingml/2006/main">
@@ -883,7 +883,7 @@
           <a:lstStyle xmlns:a="http://schemas.openxmlformats.org/drawingml/2006/main"/>
           <a:p xmlns:a="http://schemas.openxmlformats.org/drawingml/2006/main">
             <a:r>
-              <a:t>ผลอัตโนมัติอยู่ docs/ui-evidence/results.json และ http-results.json ไม่ใช่ผลรัน scanner จริง หลักฐาน screenshots แสดงชัดว่าโหมด mock ต้องให้ทุกคนลอง Scan/Cancel/Reveal หลังรวมงาน ทดสอบ full-drive จริง เก็บเวลาและหน่วยความจำ แล้วปรับสไลด์นี้ตามหลักฐานก่อนนำเสนอ ไม่อ้างเร็วขึ้นหรือแม่นยำกว่าต้นแบบโดยไม่มีผลวัด</a:t>
+              <a:t>ผลอัตโนมัติอยู่ docs/ui-evidence/results.json, http-results.json และ review-results.json ชุด review ใช้ Python HTTP กับ SQLite จริงและข้อมูลทดสอบ แก้ยอด root, รายละเอียด issues และ status.error แล้ว ไม่ใช่ผลรัน scanner จริง หลักฐาน screenshots แสดงชัดว่าโหมด mock ต้องให้ทุกคนลอง Scan/Cancel/Reveal หลังรวมงาน ทดสอบ full-drive จริง เก็บเวลาและหน่วยความจำ แล้วปรับสไลด์นี้ตามหลักฐานก่อนนำเสนอ ไม่อ้างเร็วขึ้นหรือแม่นยำกว่าต้นแบบโดยไม่มีผลวัด</a:t>
             </a:r>
           </a:p>
         </p:txBody>
@@ -951,7 +951,7 @@
   </p:cSld>
   <p:clrMap bg1="lt1" tx1="dk1" bg2="lt2" tx2="dk2" accent1="accent1" accent2="accent2" accent3="accent3" accent4="accent4" accent5="accent5" accent6="accent6" hlink="hlink" folHlink="folHlink"/>
   <p:sldLayoutIdLst>
-    <p:sldLayoutId xmlns:r="http://schemas.openxmlformats.org/officeDocument/2006/relationships" id="2147483649" r:id="R98b1d586d01e4507"/>
+    <p:sldLayoutId xmlns:r="http://schemas.openxmlformats.org/officeDocument/2006/relationships" id="2147483649" r:id="R9102da400d2e4dd3"/>
   </p:sldLayoutIdLst>
   <p:txStyles>
     <p:titleStyle>
@@ -1502,7 +1502,7 @@
           <p:cNvPr id="8" name="">
             <a:extLst xmlns:a="http://schemas.openxmlformats.org/drawingml/2006/main">
               <a:ext uri="{FF2B5EF4-FFF2-40B4-BE49-F238E27FC236}">
-                <a16:creationId xmlns:a16="http://schemas.microsoft.com/office/drawing/2014/main" id="{4F2E9942-51EF-41AC-8561-DDF3262949AE}"/>
+                <a16:creationId xmlns:a16="http://schemas.microsoft.com/office/drawing/2014/main" id="{C941DDA4-3FBE-4602-8F1C-47E77EF85327}"/>
               </a:ext>
             </a:extLst>
           </p:cNvPr>
@@ -1559,7 +1559,7 @@
           <p:cNvPr id="2" name="">
             <a:extLst xmlns:a="http://schemas.openxmlformats.org/drawingml/2006/main">
               <a:ext uri="{FF2B5EF4-FFF2-40B4-BE49-F238E27FC236}">
-                <a16:creationId xmlns:a16="http://schemas.microsoft.com/office/drawing/2014/main" id="{CD10899C-A30D-4B06-91F5-F9D23758C5EE}"/>
+                <a16:creationId xmlns:a16="http://schemas.microsoft.com/office/drawing/2014/main" id="{B1A2F390-200C-46F1-800C-15F1C8F77073}"/>
               </a:ext>
             </a:extLst>
           </p:cNvPr>
@@ -1616,7 +1616,7 @@
           <p:cNvPr id="3" name="">
             <a:extLst xmlns:a="http://schemas.openxmlformats.org/drawingml/2006/main">
               <a:ext uri="{FF2B5EF4-FFF2-40B4-BE49-F238E27FC236}">
-                <a16:creationId xmlns:a16="http://schemas.microsoft.com/office/drawing/2014/main" id="{8FE7DCD8-48A3-416D-9DCB-F08D5AF80265}"/>
+                <a16:creationId xmlns:a16="http://schemas.microsoft.com/office/drawing/2014/main" id="{472178C4-2B37-4BB0-98AC-A22D6D1A0A84}"/>
               </a:ext>
             </a:extLst>
           </p:cNvPr>
@@ -1673,7 +1673,7 @@
           <p:cNvPr id="4" name="">
             <a:extLst xmlns:a="http://schemas.openxmlformats.org/drawingml/2006/main">
               <a:ext uri="{FF2B5EF4-FFF2-40B4-BE49-F238E27FC236}">
-                <a16:creationId xmlns:a16="http://schemas.microsoft.com/office/drawing/2014/main" id="{01D5B27E-65DE-4FAF-AD69-AF6B741C1A09}"/>
+                <a16:creationId xmlns:a16="http://schemas.microsoft.com/office/drawing/2014/main" id="{135E674A-E341-45FC-B2B1-97A211A89ACA}"/>
               </a:ext>
             </a:extLst>
           </p:cNvPr>
@@ -1730,7 +1730,7 @@
           <p:cNvPr id="5" name="">
             <a:extLst xmlns:a="http://schemas.openxmlformats.org/drawingml/2006/main">
               <a:ext uri="{FF2B5EF4-FFF2-40B4-BE49-F238E27FC236}">
-                <a16:creationId xmlns:a16="http://schemas.microsoft.com/office/drawing/2014/main" id="{9D5F76E9-8D93-43F1-A173-DE00D79A182B}"/>
+                <a16:creationId xmlns:a16="http://schemas.microsoft.com/office/drawing/2014/main" id="{F3EF8171-A677-4761-AC98-7A6DA881926B}"/>
               </a:ext>
             </a:extLst>
           </p:cNvPr>
@@ -1791,7 +1791,7 @@
           <p:nvPr/>
         </p:nvPicPr>
         <p:blipFill>
-          <a:blip xmlns:r="http://schemas.openxmlformats.org/officeDocument/2006/relationships" xmlns:a="http://schemas.openxmlformats.org/drawingml/2006/main" r:embed="R62ff5a9049804860"/>
+          <a:blip xmlns:r="http://schemas.openxmlformats.org/officeDocument/2006/relationships" xmlns:a="http://schemas.openxmlformats.org/drawingml/2006/main" r:embed="R144c5828747f47d2"/>
           <a:stretch xmlns:a="http://schemas.openxmlformats.org/drawingml/2006/main"/>
         </p:blipFill>
         <p:spPr>
@@ -1809,7 +1809,7 @@
           <p:cNvPr id="7" name="">
             <a:extLst xmlns:a="http://schemas.openxmlformats.org/drawingml/2006/main">
               <a:ext uri="{FF2B5EF4-FFF2-40B4-BE49-F238E27FC236}">
-                <a16:creationId xmlns:a16="http://schemas.microsoft.com/office/drawing/2014/main" id="{36E3A188-BE09-43AB-A443-05ABBEEB9FAA}"/>
+                <a16:creationId xmlns:a16="http://schemas.microsoft.com/office/drawing/2014/main" id="{E5C145E5-1EB1-459C-B789-E5454E2C9F7E}"/>
               </a:ext>
             </a:extLst>
           </p:cNvPr>
@@ -1864,7 +1864,7 @@
     </p:spTree>
     <p:extLst>
       <p:ext uri="{BB962C8B-B14F-4D97-AF65-F5344CB8AC3E}">
-        <p14:creationId xmlns:p14="http://schemas.microsoft.com/office/powerpoint/2010/main" val="1612237983"/>
+        <p14:creationId xmlns:p14="http://schemas.microsoft.com/office/powerpoint/2010/main" val="309886213"/>
       </p:ext>
     </p:extLst>
   </p:cSld>
@@ -1895,7 +1895,7 @@
           <p:cNvPr id="7" name="">
             <a:extLst xmlns:a="http://schemas.openxmlformats.org/drawingml/2006/main">
               <a:ext uri="{FF2B5EF4-FFF2-40B4-BE49-F238E27FC236}">
-                <a16:creationId xmlns:a16="http://schemas.microsoft.com/office/drawing/2014/main" id="{3111BFE3-CA85-459D-BE1A-81F228A8C703}"/>
+                <a16:creationId xmlns:a16="http://schemas.microsoft.com/office/drawing/2014/main" id="{D1E24DC9-1596-4D30-B5AC-21975C717C15}"/>
               </a:ext>
             </a:extLst>
           </p:cNvPr>
@@ -1952,7 +1952,7 @@
           <p:cNvPr id="2" name="">
             <a:extLst xmlns:a="http://schemas.openxmlformats.org/drawingml/2006/main">
               <a:ext uri="{FF2B5EF4-FFF2-40B4-BE49-F238E27FC236}">
-                <a16:creationId xmlns:a16="http://schemas.microsoft.com/office/drawing/2014/main" id="{2CFC3133-9142-4E49-B456-2578F82EE3D0}"/>
+                <a16:creationId xmlns:a16="http://schemas.microsoft.com/office/drawing/2014/main" id="{105CF298-E64B-4E2F-8731-71BC46713747}"/>
               </a:ext>
             </a:extLst>
           </p:cNvPr>
@@ -2009,7 +2009,7 @@
           <p:cNvPr id="3" name="">
             <a:extLst xmlns:a="http://schemas.openxmlformats.org/drawingml/2006/main">
               <a:ext uri="{FF2B5EF4-FFF2-40B4-BE49-F238E27FC236}">
-                <a16:creationId xmlns:a16="http://schemas.microsoft.com/office/drawing/2014/main" id="{A3B5B84C-05D8-437E-9C94-FC0AAAD373A8}"/>
+                <a16:creationId xmlns:a16="http://schemas.microsoft.com/office/drawing/2014/main" id="{34AEAECF-E483-4FC0-9B63-34BEBA1D3D1C}"/>
               </a:ext>
             </a:extLst>
           </p:cNvPr>
@@ -2066,7 +2066,7 @@
           <p:cNvPr id="4" name="">
             <a:extLst xmlns:a="http://schemas.openxmlformats.org/drawingml/2006/main">
               <a:ext uri="{FF2B5EF4-FFF2-40B4-BE49-F238E27FC236}">
-                <a16:creationId xmlns:a16="http://schemas.microsoft.com/office/drawing/2014/main" id="{CE02EB02-925F-445D-89B1-8FDBB391A08D}"/>
+                <a16:creationId xmlns:a16="http://schemas.microsoft.com/office/drawing/2014/main" id="{20511C4C-540E-47CF-8E5D-62875AADB710}"/>
               </a:ext>
             </a:extLst>
           </p:cNvPr>
@@ -2123,7 +2123,7 @@
           <p:cNvPr id="5" name="">
             <a:extLst xmlns:a="http://schemas.openxmlformats.org/drawingml/2006/main">
               <a:ext uri="{FF2B5EF4-FFF2-40B4-BE49-F238E27FC236}">
-                <a16:creationId xmlns:a16="http://schemas.microsoft.com/office/drawing/2014/main" id="{8E3A7758-5D70-499D-ABEF-675552B22EF6}"/>
+                <a16:creationId xmlns:a16="http://schemas.microsoft.com/office/drawing/2014/main" id="{6FB4CCAF-BF7E-4157-B9B3-D223EC89E4AF}"/>
               </a:ext>
             </a:extLst>
           </p:cNvPr>
@@ -2180,7 +2180,7 @@
           <p:cNvPr id="6" name="">
             <a:extLst xmlns:a="http://schemas.openxmlformats.org/drawingml/2006/main">
               <a:ext uri="{FF2B5EF4-FFF2-40B4-BE49-F238E27FC236}">
-                <a16:creationId xmlns:a16="http://schemas.microsoft.com/office/drawing/2014/main" id="{D969929B-6A2E-4196-9CCD-E0C3E98A0DF6}"/>
+                <a16:creationId xmlns:a16="http://schemas.microsoft.com/office/drawing/2014/main" id="{55D4A0AC-6F58-4F87-A18E-9118247F9823}"/>
               </a:ext>
             </a:extLst>
           </p:cNvPr>
@@ -2235,7 +2235,7 @@
     </p:spTree>
     <p:extLst>
       <p:ext uri="{BB962C8B-B14F-4D97-AF65-F5344CB8AC3E}">
-        <p14:creationId xmlns:p14="http://schemas.microsoft.com/office/powerpoint/2010/main" val="2026880972"/>
+        <p14:creationId xmlns:p14="http://schemas.microsoft.com/office/powerpoint/2010/main" val="1596579199"/>
       </p:ext>
     </p:extLst>
   </p:cSld>
@@ -2266,7 +2266,7 @@
           <p:cNvPr id="8" name="">
             <a:extLst xmlns:a="http://schemas.openxmlformats.org/drawingml/2006/main">
               <a:ext uri="{FF2B5EF4-FFF2-40B4-BE49-F238E27FC236}">
-                <a16:creationId xmlns:a16="http://schemas.microsoft.com/office/drawing/2014/main" id="{BC019F5E-B033-437A-9185-7F750E81B914}"/>
+                <a16:creationId xmlns:a16="http://schemas.microsoft.com/office/drawing/2014/main" id="{65D1D18C-2069-4394-9D28-BFB30308117B}"/>
               </a:ext>
             </a:extLst>
           </p:cNvPr>
@@ -2323,7 +2323,7 @@
           <p:cNvPr id="2" name="">
             <a:extLst xmlns:a="http://schemas.openxmlformats.org/drawingml/2006/main">
               <a:ext uri="{FF2B5EF4-FFF2-40B4-BE49-F238E27FC236}">
-                <a16:creationId xmlns:a16="http://schemas.microsoft.com/office/drawing/2014/main" id="{B339604B-A128-49D6-9861-A82BFD0E90FA}"/>
+                <a16:creationId xmlns:a16="http://schemas.microsoft.com/office/drawing/2014/main" id="{A4682F8A-E1D7-4A90-BD9D-CD7178A221DD}"/>
               </a:ext>
             </a:extLst>
           </p:cNvPr>
@@ -2380,7 +2380,7 @@
           <p:cNvPr id="3" name="">
             <a:extLst xmlns:a="http://schemas.openxmlformats.org/drawingml/2006/main">
               <a:ext uri="{FF2B5EF4-FFF2-40B4-BE49-F238E27FC236}">
-                <a16:creationId xmlns:a16="http://schemas.microsoft.com/office/drawing/2014/main" id="{0C667DF0-D6FC-4EF3-BA5A-A0CB203D05FF}"/>
+                <a16:creationId xmlns:a16="http://schemas.microsoft.com/office/drawing/2014/main" id="{6DBF2E5C-5167-49FA-86C9-EB4D182363E8}"/>
               </a:ext>
             </a:extLst>
           </p:cNvPr>
@@ -2437,7 +2437,7 @@
           <p:cNvPr id="4" name="">
             <a:extLst xmlns:a="http://schemas.openxmlformats.org/drawingml/2006/main">
               <a:ext uri="{FF2B5EF4-FFF2-40B4-BE49-F238E27FC236}">
-                <a16:creationId xmlns:a16="http://schemas.microsoft.com/office/drawing/2014/main" id="{D798EC54-C8BF-49AB-B064-BD3D7AA20EBD}"/>
+                <a16:creationId xmlns:a16="http://schemas.microsoft.com/office/drawing/2014/main" id="{AA91F810-E2D6-41F2-BE06-675B36FE821B}"/>
               </a:ext>
             </a:extLst>
           </p:cNvPr>
@@ -2494,7 +2494,7 @@
           <p:cNvPr id="5" name="">
             <a:extLst xmlns:a="http://schemas.openxmlformats.org/drawingml/2006/main">
               <a:ext uri="{FF2B5EF4-FFF2-40B4-BE49-F238E27FC236}">
-                <a16:creationId xmlns:a16="http://schemas.microsoft.com/office/drawing/2014/main" id="{C517D999-7546-4CCE-9A55-F60FF2292A82}"/>
+                <a16:creationId xmlns:a16="http://schemas.microsoft.com/office/drawing/2014/main" id="{325F4285-7B5F-4340-BD80-9116B03BA143}"/>
               </a:ext>
             </a:extLst>
           </p:cNvPr>
@@ -2551,7 +2551,7 @@
           <p:cNvPr id="6" name="">
             <a:extLst xmlns:a="http://schemas.openxmlformats.org/drawingml/2006/main">
               <a:ext uri="{FF2B5EF4-FFF2-40B4-BE49-F238E27FC236}">
-                <a16:creationId xmlns:a16="http://schemas.microsoft.com/office/drawing/2014/main" id="{98034DE4-0EEF-44BE-A208-317248F7394E}"/>
+                <a16:creationId xmlns:a16="http://schemas.microsoft.com/office/drawing/2014/main" id="{B7F5C104-00A1-463D-AE7C-7619E901B690}"/>
               </a:ext>
             </a:extLst>
           </p:cNvPr>
@@ -2608,7 +2608,7 @@
           <p:cNvPr id="7" name="">
             <a:extLst xmlns:a="http://schemas.openxmlformats.org/drawingml/2006/main">
               <a:ext uri="{FF2B5EF4-FFF2-40B4-BE49-F238E27FC236}">
-                <a16:creationId xmlns:a16="http://schemas.microsoft.com/office/drawing/2014/main" id="{80396D4C-7DCC-4065-BB9F-D8C2B3867481}"/>
+                <a16:creationId xmlns:a16="http://schemas.microsoft.com/office/drawing/2014/main" id="{2AE75A5D-0C06-4808-83BD-6E3D2C085257}"/>
               </a:ext>
             </a:extLst>
           </p:cNvPr>
@@ -2663,7 +2663,7 @@
     </p:spTree>
     <p:extLst>
       <p:ext uri="{BB962C8B-B14F-4D97-AF65-F5344CB8AC3E}">
-        <p14:creationId xmlns:p14="http://schemas.microsoft.com/office/powerpoint/2010/main" val="184821287"/>
+        <p14:creationId xmlns:p14="http://schemas.microsoft.com/office/powerpoint/2010/main" val="1496610088"/>
       </p:ext>
     </p:extLst>
   </p:cSld>
@@ -2694,7 +2694,7 @@
           <p:cNvPr id="8" name="">
             <a:extLst xmlns:a="http://schemas.openxmlformats.org/drawingml/2006/main">
               <a:ext uri="{FF2B5EF4-FFF2-40B4-BE49-F238E27FC236}">
-                <a16:creationId xmlns:a16="http://schemas.microsoft.com/office/drawing/2014/main" id="{8A50C6AB-CF4E-4327-9574-0B2B1E399A7E}"/>
+                <a16:creationId xmlns:a16="http://schemas.microsoft.com/office/drawing/2014/main" id="{FA573774-3ED2-46E0-9000-70560A270B2B}"/>
               </a:ext>
             </a:extLst>
           </p:cNvPr>
@@ -2751,7 +2751,7 @@
           <p:cNvPr id="2" name="">
             <a:extLst xmlns:a="http://schemas.openxmlformats.org/drawingml/2006/main">
               <a:ext uri="{FF2B5EF4-FFF2-40B4-BE49-F238E27FC236}">
-                <a16:creationId xmlns:a16="http://schemas.microsoft.com/office/drawing/2014/main" id="{E9C68C5D-BE83-497B-A465-EFD4B93CCF2D}"/>
+                <a16:creationId xmlns:a16="http://schemas.microsoft.com/office/drawing/2014/main" id="{F7BC19B4-BB09-4C9F-BC8D-35E7CBFC9F21}"/>
               </a:ext>
             </a:extLst>
           </p:cNvPr>
@@ -2808,7 +2808,7 @@
           <p:cNvPr id="3" name="">
             <a:extLst xmlns:a="http://schemas.openxmlformats.org/drawingml/2006/main">
               <a:ext uri="{FF2B5EF4-FFF2-40B4-BE49-F238E27FC236}">
-                <a16:creationId xmlns:a16="http://schemas.microsoft.com/office/drawing/2014/main" id="{A5C98143-F12C-456F-A794-82671327AE52}"/>
+                <a16:creationId xmlns:a16="http://schemas.microsoft.com/office/drawing/2014/main" id="{8DA52842-AF26-4B94-A9B4-1EE52E5E7001}"/>
               </a:ext>
             </a:extLst>
           </p:cNvPr>
@@ -2865,7 +2865,7 @@
           <p:cNvPr id="4" name="">
             <a:extLst xmlns:a="http://schemas.openxmlformats.org/drawingml/2006/main">
               <a:ext uri="{FF2B5EF4-FFF2-40B4-BE49-F238E27FC236}">
-                <a16:creationId xmlns:a16="http://schemas.microsoft.com/office/drawing/2014/main" id="{4BFA9F6D-D1BA-4FCD-AE6B-E2BAFC8C18CD}"/>
+                <a16:creationId xmlns:a16="http://schemas.microsoft.com/office/drawing/2014/main" id="{E99BA8A3-5850-4F85-B7C1-D64D1B277D71}"/>
               </a:ext>
             </a:extLst>
           </p:cNvPr>
@@ -2922,7 +2922,7 @@
           <p:cNvPr id="5" name="">
             <a:extLst xmlns:a="http://schemas.openxmlformats.org/drawingml/2006/main">
               <a:ext uri="{FF2B5EF4-FFF2-40B4-BE49-F238E27FC236}">
-                <a16:creationId xmlns:a16="http://schemas.microsoft.com/office/drawing/2014/main" id="{23FDFE1A-4197-4209-9E84-4FA5278C5C29}"/>
+                <a16:creationId xmlns:a16="http://schemas.microsoft.com/office/drawing/2014/main" id="{4810452F-B319-4A43-8BC8-5DBE9D81DE76}"/>
               </a:ext>
             </a:extLst>
           </p:cNvPr>
@@ -2979,7 +2979,7 @@
           <p:cNvPr id="6" name="">
             <a:extLst xmlns:a="http://schemas.openxmlformats.org/drawingml/2006/main">
               <a:ext uri="{FF2B5EF4-FFF2-40B4-BE49-F238E27FC236}">
-                <a16:creationId xmlns:a16="http://schemas.microsoft.com/office/drawing/2014/main" id="{C3980969-519C-4F3E-B15B-2A0113129D59}"/>
+                <a16:creationId xmlns:a16="http://schemas.microsoft.com/office/drawing/2014/main" id="{3C9E811B-EC57-4C8A-9353-E129B7B7F4BC}"/>
               </a:ext>
             </a:extLst>
           </p:cNvPr>
@@ -3036,7 +3036,7 @@
           <p:cNvPr id="7" name="">
             <a:extLst xmlns:a="http://schemas.openxmlformats.org/drawingml/2006/main">
               <a:ext uri="{FF2B5EF4-FFF2-40B4-BE49-F238E27FC236}">
-                <a16:creationId xmlns:a16="http://schemas.microsoft.com/office/drawing/2014/main" id="{0A9FD741-BD0E-4F18-A3AF-D721D3EE54FE}"/>
+                <a16:creationId xmlns:a16="http://schemas.microsoft.com/office/drawing/2014/main" id="{A2F9B802-C187-41DB-8BF9-459390BCD598}"/>
               </a:ext>
             </a:extLst>
           </p:cNvPr>
@@ -3091,7 +3091,7 @@
     </p:spTree>
     <p:extLst>
       <p:ext uri="{BB962C8B-B14F-4D97-AF65-F5344CB8AC3E}">
-        <p14:creationId xmlns:p14="http://schemas.microsoft.com/office/powerpoint/2010/main" val="2059329297"/>
+        <p14:creationId xmlns:p14="http://schemas.microsoft.com/office/powerpoint/2010/main" val="2114248175"/>
       </p:ext>
     </p:extLst>
   </p:cSld>
@@ -3122,7 +3122,7 @@
           <p:cNvPr id="8" name="">
             <a:extLst xmlns:a="http://schemas.openxmlformats.org/drawingml/2006/main">
               <a:ext uri="{FF2B5EF4-FFF2-40B4-BE49-F238E27FC236}">
-                <a16:creationId xmlns:a16="http://schemas.microsoft.com/office/drawing/2014/main" id="{4210CD25-136A-492E-A0E2-391B208B96E5}"/>
+                <a16:creationId xmlns:a16="http://schemas.microsoft.com/office/drawing/2014/main" id="{029FF6DE-5F07-4E69-8177-19CFE020F0AA}"/>
               </a:ext>
             </a:extLst>
           </p:cNvPr>
@@ -3179,7 +3179,7 @@
           <p:cNvPr id="2" name="">
             <a:extLst xmlns:a="http://schemas.openxmlformats.org/drawingml/2006/main">
               <a:ext uri="{FF2B5EF4-FFF2-40B4-BE49-F238E27FC236}">
-                <a16:creationId xmlns:a16="http://schemas.microsoft.com/office/drawing/2014/main" id="{02B56B49-486C-43D7-A7E3-2E88E5303945}"/>
+                <a16:creationId xmlns:a16="http://schemas.microsoft.com/office/drawing/2014/main" id="{A9EFE50E-47EF-482C-9DBA-10A83DAB99AB}"/>
               </a:ext>
             </a:extLst>
           </p:cNvPr>
@@ -3236,7 +3236,7 @@
           <p:cNvPr id="3" name="">
             <a:extLst xmlns:a="http://schemas.openxmlformats.org/drawingml/2006/main">
               <a:ext uri="{FF2B5EF4-FFF2-40B4-BE49-F238E27FC236}">
-                <a16:creationId xmlns:a16="http://schemas.microsoft.com/office/drawing/2014/main" id="{F00D85B3-2056-4542-9364-4810F0583B32}"/>
+                <a16:creationId xmlns:a16="http://schemas.microsoft.com/office/drawing/2014/main" id="{DB95151E-A133-4FD7-B14B-03854E7680CA}"/>
               </a:ext>
             </a:extLst>
           </p:cNvPr>
@@ -3293,7 +3293,7 @@
           <p:cNvPr id="4" name="">
             <a:extLst xmlns:a="http://schemas.openxmlformats.org/drawingml/2006/main">
               <a:ext uri="{FF2B5EF4-FFF2-40B4-BE49-F238E27FC236}">
-                <a16:creationId xmlns:a16="http://schemas.microsoft.com/office/drawing/2014/main" id="{9DCD9F47-CB40-436B-9108-28D0773AF996}"/>
+                <a16:creationId xmlns:a16="http://schemas.microsoft.com/office/drawing/2014/main" id="{896FF199-8BBF-4E7A-A654-A5AACD6DE52C}"/>
               </a:ext>
             </a:extLst>
           </p:cNvPr>
@@ -3350,7 +3350,7 @@
           <p:cNvPr id="5" name="">
             <a:extLst xmlns:a="http://schemas.openxmlformats.org/drawingml/2006/main">
               <a:ext uri="{FF2B5EF4-FFF2-40B4-BE49-F238E27FC236}">
-                <a16:creationId xmlns:a16="http://schemas.microsoft.com/office/drawing/2014/main" id="{07C13B8F-BA20-4075-BBB1-9B4AD8945D65}"/>
+                <a16:creationId xmlns:a16="http://schemas.microsoft.com/office/drawing/2014/main" id="{AE371898-4CB3-4918-87B7-17B90A5F9B86}"/>
               </a:ext>
             </a:extLst>
           </p:cNvPr>
@@ -3411,13 +3411,13 @@
           <p:nvPr/>
         </p:nvPicPr>
         <p:blipFill>
-          <a:blip xmlns:r="http://schemas.openxmlformats.org/officeDocument/2006/relationships" xmlns:a="http://schemas.openxmlformats.org/drawingml/2006/main" r:embed="R83f6814c436042d6"/>
+          <a:blip xmlns:r="http://schemas.openxmlformats.org/officeDocument/2006/relationships" xmlns:a="http://schemas.openxmlformats.org/drawingml/2006/main" r:embed="R1444ffb89f8b4ac7"/>
           <a:stretch xmlns:a="http://schemas.openxmlformats.org/drawingml/2006/main"/>
         </p:blipFill>
         <p:spPr>
           <a:xfrm xmlns:a="http://schemas.openxmlformats.org/drawingml/2006/main">
-            <a:off x="6951627" y="1476375"/>
-            <a:ext cx="3908496" cy="4619625"/>
+            <a:off x="6979917" y="1476375"/>
+            <a:ext cx="3851917" cy="4619625"/>
           </a:xfrm>
           <a:prstGeom xmlns:a="http://schemas.openxmlformats.org/drawingml/2006/main" prst="rect">
             <a:avLst/>
@@ -3429,7 +3429,7 @@
           <p:cNvPr id="7" name="">
             <a:extLst xmlns:a="http://schemas.openxmlformats.org/drawingml/2006/main">
               <a:ext uri="{FF2B5EF4-FFF2-40B4-BE49-F238E27FC236}">
-                <a16:creationId xmlns:a16="http://schemas.microsoft.com/office/drawing/2014/main" id="{1C6E651E-B616-493C-8405-1703DF5B85FD}"/>
+                <a16:creationId xmlns:a16="http://schemas.microsoft.com/office/drawing/2014/main" id="{B0B95E6C-D6BD-446F-AB7D-162E626CEDF7}"/>
               </a:ext>
             </a:extLst>
           </p:cNvPr>
@@ -3484,7 +3484,7 @@
     </p:spTree>
     <p:extLst>
       <p:ext uri="{BB962C8B-B14F-4D97-AF65-F5344CB8AC3E}">
-        <p14:creationId xmlns:p14="http://schemas.microsoft.com/office/powerpoint/2010/main" val="998515092"/>
+        <p14:creationId xmlns:p14="http://schemas.microsoft.com/office/powerpoint/2010/main" val="438899321"/>
       </p:ext>
     </p:extLst>
   </p:cSld>
@@ -3515,7 +3515,7 @@
           <p:cNvPr id="7" name="">
             <a:extLst xmlns:a="http://schemas.openxmlformats.org/drawingml/2006/main">
               <a:ext uri="{FF2B5EF4-FFF2-40B4-BE49-F238E27FC236}">
-                <a16:creationId xmlns:a16="http://schemas.microsoft.com/office/drawing/2014/main" id="{F8C9264A-3DD9-461A-89A6-E11E64285BA4}"/>
+                <a16:creationId xmlns:a16="http://schemas.microsoft.com/office/drawing/2014/main" id="{536AF4B3-1B90-4998-8F4C-807222C90C26}"/>
               </a:ext>
             </a:extLst>
           </p:cNvPr>
@@ -3572,7 +3572,7 @@
           <p:cNvPr id="2" name="">
             <a:extLst xmlns:a="http://schemas.openxmlformats.org/drawingml/2006/main">
               <a:ext uri="{FF2B5EF4-FFF2-40B4-BE49-F238E27FC236}">
-                <a16:creationId xmlns:a16="http://schemas.microsoft.com/office/drawing/2014/main" id="{7FDE1F62-0BE8-4A22-B7A8-09B4995BB400}"/>
+                <a16:creationId xmlns:a16="http://schemas.microsoft.com/office/drawing/2014/main" id="{B1F2E739-7DCD-4CFA-A390-C5F144AE0CAB}"/>
               </a:ext>
             </a:extLst>
           </p:cNvPr>
@@ -3629,7 +3629,7 @@
           <p:cNvPr id="3" name="">
             <a:extLst xmlns:a="http://schemas.openxmlformats.org/drawingml/2006/main">
               <a:ext uri="{FF2B5EF4-FFF2-40B4-BE49-F238E27FC236}">
-                <a16:creationId xmlns:a16="http://schemas.microsoft.com/office/drawing/2014/main" id="{D0FA3B1E-1EA0-43AD-A1EF-8EA1B3F812F0}"/>
+                <a16:creationId xmlns:a16="http://schemas.microsoft.com/office/drawing/2014/main" id="{2522EFF0-5D25-4740-99F0-5A4F05A4EDD6}"/>
               </a:ext>
             </a:extLst>
           </p:cNvPr>
@@ -3686,7 +3686,7 @@
           <p:cNvPr id="4" name="">
             <a:extLst xmlns:a="http://schemas.openxmlformats.org/drawingml/2006/main">
               <a:ext uri="{FF2B5EF4-FFF2-40B4-BE49-F238E27FC236}">
-                <a16:creationId xmlns:a16="http://schemas.microsoft.com/office/drawing/2014/main" id="{D8CB8221-B4E1-470E-869F-34F276572BEB}"/>
+                <a16:creationId xmlns:a16="http://schemas.microsoft.com/office/drawing/2014/main" id="{2D88B38B-1709-49D4-BDD0-BB021861E327}"/>
               </a:ext>
             </a:extLst>
           </p:cNvPr>
@@ -3743,7 +3743,7 @@
           <p:cNvPr id="5" name="">
             <a:extLst xmlns:a="http://schemas.openxmlformats.org/drawingml/2006/main">
               <a:ext uri="{FF2B5EF4-FFF2-40B4-BE49-F238E27FC236}">
-                <a16:creationId xmlns:a16="http://schemas.microsoft.com/office/drawing/2014/main" id="{BB585CD6-D746-4CDD-A833-629A8B258CB4}"/>
+                <a16:creationId xmlns:a16="http://schemas.microsoft.com/office/drawing/2014/main" id="{97F6D474-7D36-4CBF-8D1A-1A97C985A3A8}"/>
               </a:ext>
             </a:extLst>
           </p:cNvPr>
@@ -3800,7 +3800,7 @@
           <p:cNvPr id="6" name="">
             <a:extLst xmlns:a="http://schemas.openxmlformats.org/drawingml/2006/main">
               <a:ext uri="{FF2B5EF4-FFF2-40B4-BE49-F238E27FC236}">
-                <a16:creationId xmlns:a16="http://schemas.microsoft.com/office/drawing/2014/main" id="{5FD85E98-AA06-446D-9E2D-BA2F51FD3EAA}"/>
+                <a16:creationId xmlns:a16="http://schemas.microsoft.com/office/drawing/2014/main" id="{6A4AD035-13AF-4ADC-B1E3-D2A333092CAE}"/>
               </a:ext>
             </a:extLst>
           </p:cNvPr>
@@ -3855,7 +3855,7 @@
     </p:spTree>
     <p:extLst>
       <p:ext uri="{BB962C8B-B14F-4D97-AF65-F5344CB8AC3E}">
-        <p14:creationId xmlns:p14="http://schemas.microsoft.com/office/powerpoint/2010/main" val="1332060188"/>
+        <p14:creationId xmlns:p14="http://schemas.microsoft.com/office/powerpoint/2010/main" val="1922532908"/>
       </p:ext>
     </p:extLst>
   </p:cSld>
@@ -3886,7 +3886,7 @@
           <p:cNvPr id="8" name="">
             <a:extLst xmlns:a="http://schemas.openxmlformats.org/drawingml/2006/main">
               <a:ext uri="{FF2B5EF4-FFF2-40B4-BE49-F238E27FC236}">
-                <a16:creationId xmlns:a16="http://schemas.microsoft.com/office/drawing/2014/main" id="{9D6174C7-0EA7-4B0F-B95C-3BE67FECB7B6}"/>
+                <a16:creationId xmlns:a16="http://schemas.microsoft.com/office/drawing/2014/main" id="{EB54BEA7-9346-4370-BC80-44A038521168}"/>
               </a:ext>
             </a:extLst>
           </p:cNvPr>
@@ -3943,7 +3943,7 @@
           <p:cNvPr id="2" name="">
             <a:extLst xmlns:a="http://schemas.openxmlformats.org/drawingml/2006/main">
               <a:ext uri="{FF2B5EF4-FFF2-40B4-BE49-F238E27FC236}">
-                <a16:creationId xmlns:a16="http://schemas.microsoft.com/office/drawing/2014/main" id="{31C28FCA-16BB-45BC-A4C0-812680871F2F}"/>
+                <a16:creationId xmlns:a16="http://schemas.microsoft.com/office/drawing/2014/main" id="{70D4E860-F989-4D09-AD30-4F665A84BB02}"/>
               </a:ext>
             </a:extLst>
           </p:cNvPr>
@@ -4000,7 +4000,7 @@
           <p:cNvPr id="3" name="">
             <a:extLst xmlns:a="http://schemas.openxmlformats.org/drawingml/2006/main">
               <a:ext uri="{FF2B5EF4-FFF2-40B4-BE49-F238E27FC236}">
-                <a16:creationId xmlns:a16="http://schemas.microsoft.com/office/drawing/2014/main" id="{A88345DD-EEEC-43D4-93AE-799B87BBFB9D}"/>
+                <a16:creationId xmlns:a16="http://schemas.microsoft.com/office/drawing/2014/main" id="{6554E9BB-4900-4074-B052-9981C1068B39}"/>
               </a:ext>
             </a:extLst>
           </p:cNvPr>
@@ -4057,7 +4057,7 @@
           <p:cNvPr id="4" name="">
             <a:extLst xmlns:a="http://schemas.openxmlformats.org/drawingml/2006/main">
               <a:ext uri="{FF2B5EF4-FFF2-40B4-BE49-F238E27FC236}">
-                <a16:creationId xmlns:a16="http://schemas.microsoft.com/office/drawing/2014/main" id="{DFE3016F-21BF-46D1-85EE-FA51811BC057}"/>
+                <a16:creationId xmlns:a16="http://schemas.microsoft.com/office/drawing/2014/main" id="{27908832-9C53-46C6-9F7A-C8E3C82267AC}"/>
               </a:ext>
             </a:extLst>
           </p:cNvPr>
@@ -4114,7 +4114,7 @@
           <p:cNvPr id="5" name="">
             <a:extLst xmlns:a="http://schemas.openxmlformats.org/drawingml/2006/main">
               <a:ext uri="{FF2B5EF4-FFF2-40B4-BE49-F238E27FC236}">
-                <a16:creationId xmlns:a16="http://schemas.microsoft.com/office/drawing/2014/main" id="{2D1F9736-3F1F-42D0-A8FA-25C179F47D5F}"/>
+                <a16:creationId xmlns:a16="http://schemas.microsoft.com/office/drawing/2014/main" id="{ADC5EF68-6F4A-4AA9-A245-29D44EB18015}"/>
               </a:ext>
             </a:extLst>
           </p:cNvPr>
@@ -4171,7 +4171,7 @@
           <p:cNvPr id="6" name="">
             <a:extLst xmlns:a="http://schemas.openxmlformats.org/drawingml/2006/main">
               <a:ext uri="{FF2B5EF4-FFF2-40B4-BE49-F238E27FC236}">
-                <a16:creationId xmlns:a16="http://schemas.microsoft.com/office/drawing/2014/main" id="{A2A92491-F622-47EC-9F71-62BDF3AD4556}"/>
+                <a16:creationId xmlns:a16="http://schemas.microsoft.com/office/drawing/2014/main" id="{2E86643B-4D2C-4241-8B94-8650412B9386}"/>
               </a:ext>
             </a:extLst>
           </p:cNvPr>
@@ -4228,7 +4228,7 @@
           <p:cNvPr id="7" name="">
             <a:extLst xmlns:a="http://schemas.openxmlformats.org/drawingml/2006/main">
               <a:ext uri="{FF2B5EF4-FFF2-40B4-BE49-F238E27FC236}">
-                <a16:creationId xmlns:a16="http://schemas.microsoft.com/office/drawing/2014/main" id="{A8E57554-02F4-4D74-8785-49468FD8DDDB}"/>
+                <a16:creationId xmlns:a16="http://schemas.microsoft.com/office/drawing/2014/main" id="{449AB7BD-E531-47CC-82FA-7A39A53092DB}"/>
               </a:ext>
             </a:extLst>
           </p:cNvPr>
@@ -4283,7 +4283,7 @@
     </p:spTree>
     <p:extLst>
       <p:ext uri="{BB962C8B-B14F-4D97-AF65-F5344CB8AC3E}">
-        <p14:creationId xmlns:p14="http://schemas.microsoft.com/office/powerpoint/2010/main" val="1301359474"/>
+        <p14:creationId xmlns:p14="http://schemas.microsoft.com/office/powerpoint/2010/main" val="1601341294"/>
       </p:ext>
     </p:extLst>
   </p:cSld>

</xml_diff>

<commit_message>
docs: align presentation and notes with review feedback
</commit_message>
<xml_diff>
--- a/docs/CoreSpace-Theeramet.pptx
+++ b/docs/CoreSpace-Theeramet.pptx
@@ -2,19 +2,19 @@
 <file path=ppt/presentation.xml><?xml version="1.0" encoding="utf-8"?>
 <p:presentation xmlns:p="http://schemas.openxmlformats.org/presentationml/2006/main">
   <p:sldMasterIdLst>
-    <p:sldMasterId xmlns:r="http://schemas.openxmlformats.org/officeDocument/2006/relationships" id="2147483648" r:id="Re2521e027bb84be0"/>
+    <p:sldMasterId xmlns:r="http://schemas.openxmlformats.org/officeDocument/2006/relationships" id="2147483648" r:id="R301afa619e1e437f"/>
   </p:sldMasterIdLst>
   <p:notesMasterIdLst>
-    <p:notesMasterId xmlns:r="http://schemas.openxmlformats.org/officeDocument/2006/relationships" r:id="Re4ac29cf83b848a7"/>
+    <p:notesMasterId xmlns:r="http://schemas.openxmlformats.org/officeDocument/2006/relationships" r:id="Re26d949b645644c4"/>
   </p:notesMasterIdLst>
   <p:sldIdLst>
-    <p:sldId xmlns:r="http://schemas.openxmlformats.org/officeDocument/2006/relationships" id="256" r:id="Rd721f0fe8ce2456f"/>
-    <p:sldId xmlns:r="http://schemas.openxmlformats.org/officeDocument/2006/relationships" id="257" r:id="R028616e483664481"/>
-    <p:sldId xmlns:r="http://schemas.openxmlformats.org/officeDocument/2006/relationships" id="258" r:id="Rac607d536e644639"/>
-    <p:sldId xmlns:r="http://schemas.openxmlformats.org/officeDocument/2006/relationships" id="259" r:id="R543154fc5f2a4ddc"/>
-    <p:sldId xmlns:r="http://schemas.openxmlformats.org/officeDocument/2006/relationships" id="260" r:id="R517112c6e5b5412c"/>
-    <p:sldId xmlns:r="http://schemas.openxmlformats.org/officeDocument/2006/relationships" id="261" r:id="Ra95a976e0eca41bd"/>
-    <p:sldId xmlns:r="http://schemas.openxmlformats.org/officeDocument/2006/relationships" id="262" r:id="R871543ee694647d0"/>
+    <p:sldId xmlns:r="http://schemas.openxmlformats.org/officeDocument/2006/relationships" id="256" r:id="R33cff489e50c4402"/>
+    <p:sldId xmlns:r="http://schemas.openxmlformats.org/officeDocument/2006/relationships" id="257" r:id="Rd6321fa323064996"/>
+    <p:sldId xmlns:r="http://schemas.openxmlformats.org/officeDocument/2006/relationships" id="258" r:id="Rff15e6505bbb4c62"/>
+    <p:sldId xmlns:r="http://schemas.openxmlformats.org/officeDocument/2006/relationships" id="259" r:id="R9aa51cf2fbc54ed0"/>
+    <p:sldId xmlns:r="http://schemas.openxmlformats.org/officeDocument/2006/relationships" id="260" r:id="Rc0ff31eacb744b95"/>
+    <p:sldId xmlns:r="http://schemas.openxmlformats.org/officeDocument/2006/relationships" id="261" r:id="Rc22473d58fdb4703"/>
+    <p:sldId xmlns:r="http://schemas.openxmlformats.org/officeDocument/2006/relationships" id="262" r:id="R3c305c27c9e1408d"/>
   </p:sldIdLst>
   <p:sldSz cx="12192000" cy="6858000"/>
   <p:notesSz cx="6858000" cy="9144000"/>
@@ -813,7 +813,7 @@
           <a:lstStyle xmlns:a="http://schemas.openxmlformats.org/drawingml/2006/main"/>
           <a:p xmlns:a="http://schemas.openxmlformats.org/drawingml/2006/main">
             <a:r>
-              <a:t>ก่อนวันส่งต้องเปลี่ยนมาเดโมด้วย backend C/WSL จริงบน Windows ถ้ายังไม่พร้อม ให้บอกว่าเป็นการสาธิต UI ผ่าน simulator เปิด /?mock=1 แล้วรอ partial เลือก many-folders/deep และทดลอง error ใน Reveal งานนานใช้ scenario slow สำหรับ Cancel ผลเต็มไดรฟ์ต้องมีรหัสงานจริงที่สแกนจบแล้ว ห้ามอ้างผล mock ว่าเป็นผลสดหรือ benchmark</a:t>
+              <a:t>ก่อนวันส่งต้องเปลี่ยนมาเดโมด้วย backend C/WSL จริงบน Windows ถ้ายังไม่พร้อม ให้บอกว่าเป็นการสาธิต UI ผ่าน simulator เปิด /?mock=1 แล้วรอ partial เลือก many-folders/deep และทดลอง error ใน Reveal งานนานใช้ scenario slow สำหรับ Cancel ผลเต็มไดรฟ์ต้องมีรหัสงานจริงที่สแกนจบแล้ว ผลจาก mock ต้องระบุว่าเป็นข้อมูลสมมติ</a:t>
             </a:r>
           </a:p>
         </p:txBody>
@@ -883,7 +883,7 @@
           <a:lstStyle xmlns:a="http://schemas.openxmlformats.org/drawingml/2006/main"/>
           <a:p xmlns:a="http://schemas.openxmlformats.org/drawingml/2006/main">
             <a:r>
-              <a:t>ผลอัตโนมัติอยู่ docs/ui-evidence/results.json, http-results.json และ review-results.json ชุด review ใช้ Python HTTP กับ SQLite จริงและข้อมูลทดสอบ แก้ยอด root, รายละเอียด issues และ status.error แล้ว ไม่ใช่ผลรัน scanner จริง หลักฐาน screenshots แสดงชัดว่าโหมด mock ต้องให้ทุกคนลอง Scan/Cancel/Reveal หลังรวมงาน ทดสอบ full-drive จริง เก็บเวลาและหน่วยความจำ แล้วปรับสไลด์นี้ตามหลักฐานก่อนนำเสนอ ไม่อ้างเร็วขึ้นหรือแม่นยำกว่าต้นแบบโดยไม่มีผลวัด</a:t>
+              <a:t>ผลอัตโนมัติอยู่ docs/ui-evidence/results.json, http-results.json และ review-results.json ชุด review ใช้ Python HTTP กับ SQLite จริงและข้อมูลทดสอบ ตรวจยอด root รายการปัญหา และข้อความงานล้มเหลวแล้ว ผลนี้ยังไม่ยืนยัน C จริง ภาพหน้าจอบางภาพเป็นโหมด mock หลังรวม C ให้ทั้งกลุ่มลอง Scan/Cancel/Reveal และสแกนทั้งไดรฟ์ ตรวจจำนวนไฟล์และโฟลเดอร์ ขนาด ความถูกต้องของรายการ ผลการยกเลิก และข้อจำกัด เติมเฉพาะผลที่รันจริงก่อนนำเสนอ ตาม SPEC วันที่ 5 ต.ค. ไม่มีงาน benchmark หรือวัดหน่วยความจำ</a:t>
             </a:r>
           </a:p>
         </p:txBody>
@@ -951,7 +951,7 @@
   </p:cSld>
   <p:clrMap bg1="lt1" tx1="dk1" bg2="lt2" tx2="dk2" accent1="accent1" accent2="accent2" accent3="accent3" accent4="accent4" accent5="accent5" accent6="accent6" hlink="hlink" folHlink="folHlink"/>
   <p:sldLayoutIdLst>
-    <p:sldLayoutId xmlns:r="http://schemas.openxmlformats.org/officeDocument/2006/relationships" id="2147483649" r:id="R9102da400d2e4dd3"/>
+    <p:sldLayoutId xmlns:r="http://schemas.openxmlformats.org/officeDocument/2006/relationships" id="2147483649" r:id="Rc0987c6479134a24"/>
   </p:sldLayoutIdLst>
   <p:txStyles>
     <p:titleStyle>
@@ -1531,6 +1531,7 @@
           <a:lstStyle xmlns:a="http://schemas.openxmlformats.org/drawingml/2006/main"/>
           <a:p xmlns:a="http://schemas.openxmlformats.org/drawingml/2006/main">
             <a:pPr>
+              <a:buNone/>
               <a:defRPr sz="5400" b="1">
                 <a:solidFill>
                   <a:srgbClr val="3C3A39"/>
@@ -1588,6 +1589,7 @@
           <a:lstStyle xmlns:a="http://schemas.openxmlformats.org/drawingml/2006/main"/>
           <a:p xmlns:a="http://schemas.openxmlformats.org/drawingml/2006/main">
             <a:pPr>
+              <a:buNone/>
               <a:defRPr sz="2850" b="0">
                 <a:solidFill>
                   <a:srgbClr val="3C3A39"/>
@@ -1645,6 +1647,7 @@
           <a:lstStyle xmlns:a="http://schemas.openxmlformats.org/drawingml/2006/main"/>
           <a:p xmlns:a="http://schemas.openxmlformats.org/drawingml/2006/main">
             <a:pPr>
+              <a:buNone/>
               <a:defRPr sz="1950" b="0">
                 <a:solidFill>
                   <a:srgbClr val="3C3A39"/>
@@ -1702,6 +1705,7 @@
           <a:lstStyle xmlns:a="http://schemas.openxmlformats.org/drawingml/2006/main"/>
           <a:p xmlns:a="http://schemas.openxmlformats.org/drawingml/2006/main">
             <a:pPr>
+              <a:buNone/>
               <a:defRPr sz="1950" b="0">
                 <a:solidFill>
                   <a:srgbClr val="3C3A39"/>
@@ -1759,6 +1763,7 @@
           <a:lstStyle xmlns:a="http://schemas.openxmlformats.org/drawingml/2006/main"/>
           <a:p xmlns:a="http://schemas.openxmlformats.org/drawingml/2006/main">
             <a:pPr>
+              <a:buNone/>
               <a:defRPr sz="1950" b="0">
                 <a:solidFill>
                   <a:srgbClr val="3C3A39"/>
@@ -1784,14 +1789,14 @@
       </p:sp>
       <p:pic>
         <p:nvPicPr>
-          <p:cNvPr id="13" name=""/>
+          <p:cNvPr id="15" name=""/>
           <p:cNvPicPr>
             <a:picLocks xmlns:a="http://schemas.openxmlformats.org/drawingml/2006/main" noChangeAspect="1"/>
           </p:cNvPicPr>
           <p:nvPr/>
         </p:nvPicPr>
         <p:blipFill>
-          <a:blip xmlns:r="http://schemas.openxmlformats.org/officeDocument/2006/relationships" xmlns:a="http://schemas.openxmlformats.org/drawingml/2006/main" r:embed="R144c5828747f47d2"/>
+          <a:blip xmlns:r="http://schemas.openxmlformats.org/officeDocument/2006/relationships" xmlns:a="http://schemas.openxmlformats.org/drawingml/2006/main" r:embed="Re6cf2ddcaf29465b"/>
           <a:stretch xmlns:a="http://schemas.openxmlformats.org/drawingml/2006/main"/>
         </p:blipFill>
         <p:spPr>
@@ -1838,6 +1843,7 @@
           <a:lstStyle xmlns:a="http://schemas.openxmlformats.org/drawingml/2006/main"/>
           <a:p xmlns:a="http://schemas.openxmlformats.org/drawingml/2006/main">
             <a:pPr>
+              <a:buNone/>
               <a:defRPr sz="1500" b="0">
                 <a:solidFill>
                   <a:srgbClr val="716E68"/>
@@ -1924,6 +1930,7 @@
           <a:lstStyle xmlns:a="http://schemas.openxmlformats.org/drawingml/2006/main"/>
           <a:p xmlns:a="http://schemas.openxmlformats.org/drawingml/2006/main">
             <a:pPr>
+              <a:buNone/>
               <a:defRPr sz="3900" b="1">
                 <a:solidFill>
                   <a:srgbClr val="3C3A39"/>
@@ -1981,6 +1988,7 @@
           <a:lstStyle xmlns:a="http://schemas.openxmlformats.org/drawingml/2006/main"/>
           <a:p xmlns:a="http://schemas.openxmlformats.org/drawingml/2006/main">
             <a:pPr>
+              <a:buNone/>
               <a:defRPr sz="2325" b="0">
                 <a:solidFill>
                   <a:srgbClr val="3C3A39"/>
@@ -2038,6 +2046,7 @@
           <a:lstStyle xmlns:a="http://schemas.openxmlformats.org/drawingml/2006/main"/>
           <a:p xmlns:a="http://schemas.openxmlformats.org/drawingml/2006/main">
             <a:pPr>
+              <a:buNone/>
               <a:defRPr sz="2325" b="0">
                 <a:solidFill>
                   <a:srgbClr val="3C3A39"/>
@@ -2095,6 +2104,7 @@
           <a:lstStyle xmlns:a="http://schemas.openxmlformats.org/drawingml/2006/main"/>
           <a:p xmlns:a="http://schemas.openxmlformats.org/drawingml/2006/main">
             <a:pPr>
+              <a:buNone/>
               <a:defRPr sz="2325" b="0">
                 <a:solidFill>
                   <a:srgbClr val="3C3A39"/>
@@ -2152,6 +2162,7 @@
           <a:lstStyle xmlns:a="http://schemas.openxmlformats.org/drawingml/2006/main"/>
           <a:p xmlns:a="http://schemas.openxmlformats.org/drawingml/2006/main">
             <a:pPr>
+              <a:buNone/>
               <a:defRPr sz="2325" b="0">
                 <a:solidFill>
                   <a:srgbClr val="3C3A39"/>
@@ -2209,6 +2220,7 @@
           <a:lstStyle xmlns:a="http://schemas.openxmlformats.org/drawingml/2006/main"/>
           <a:p xmlns:a="http://schemas.openxmlformats.org/drawingml/2006/main">
             <a:pPr>
+              <a:buNone/>
               <a:defRPr sz="1500" b="0">
                 <a:solidFill>
                   <a:srgbClr val="716E68"/>
@@ -2295,6 +2307,7 @@
           <a:lstStyle xmlns:a="http://schemas.openxmlformats.org/drawingml/2006/main"/>
           <a:p xmlns:a="http://schemas.openxmlformats.org/drawingml/2006/main">
             <a:pPr>
+              <a:buNone/>
               <a:defRPr sz="3900" b="1">
                 <a:solidFill>
                   <a:srgbClr val="3C3A39"/>
@@ -2352,6 +2365,7 @@
           <a:lstStyle xmlns:a="http://schemas.openxmlformats.org/drawingml/2006/main"/>
           <a:p xmlns:a="http://schemas.openxmlformats.org/drawingml/2006/main">
             <a:pPr>
+              <a:buNone/>
               <a:defRPr sz="2325" b="0">
                 <a:solidFill>
                   <a:srgbClr val="3C3A39"/>
@@ -2409,6 +2423,7 @@
           <a:lstStyle xmlns:a="http://schemas.openxmlformats.org/drawingml/2006/main"/>
           <a:p xmlns:a="http://schemas.openxmlformats.org/drawingml/2006/main">
             <a:pPr>
+              <a:buNone/>
               <a:defRPr sz="2325" b="0">
                 <a:solidFill>
                   <a:srgbClr val="3C3A39"/>
@@ -2466,6 +2481,7 @@
           <a:lstStyle xmlns:a="http://schemas.openxmlformats.org/drawingml/2006/main"/>
           <a:p xmlns:a="http://schemas.openxmlformats.org/drawingml/2006/main">
             <a:pPr>
+              <a:buNone/>
               <a:defRPr sz="2325" b="0">
                 <a:solidFill>
                   <a:srgbClr val="3C3A39"/>
@@ -2523,6 +2539,7 @@
           <a:lstStyle xmlns:a="http://schemas.openxmlformats.org/drawingml/2006/main"/>
           <a:p xmlns:a="http://schemas.openxmlformats.org/drawingml/2006/main">
             <a:pPr>
+              <a:buNone/>
               <a:defRPr sz="2325" b="0">
                 <a:solidFill>
                   <a:srgbClr val="3C3A39"/>
@@ -2580,6 +2597,7 @@
           <a:lstStyle xmlns:a="http://schemas.openxmlformats.org/drawingml/2006/main"/>
           <a:p xmlns:a="http://schemas.openxmlformats.org/drawingml/2006/main">
             <a:pPr>
+              <a:buNone/>
               <a:defRPr sz="2325" b="0">
                 <a:solidFill>
                   <a:srgbClr val="3C3A39"/>
@@ -2637,6 +2655,7 @@
           <a:lstStyle xmlns:a="http://schemas.openxmlformats.org/drawingml/2006/main"/>
           <a:p xmlns:a="http://schemas.openxmlformats.org/drawingml/2006/main">
             <a:pPr>
+              <a:buNone/>
               <a:defRPr sz="1500" b="0">
                 <a:solidFill>
                   <a:srgbClr val="716E68"/>
@@ -2723,6 +2742,7 @@
           <a:lstStyle xmlns:a="http://schemas.openxmlformats.org/drawingml/2006/main"/>
           <a:p xmlns:a="http://schemas.openxmlformats.org/drawingml/2006/main">
             <a:pPr>
+              <a:buNone/>
               <a:defRPr sz="3900" b="1">
                 <a:solidFill>
                   <a:srgbClr val="3C3A39"/>
@@ -2780,6 +2800,7 @@
           <a:lstStyle xmlns:a="http://schemas.openxmlformats.org/drawingml/2006/main"/>
           <a:p xmlns:a="http://schemas.openxmlformats.org/drawingml/2006/main">
             <a:pPr>
+              <a:buNone/>
               <a:defRPr sz="2325" b="0">
                 <a:solidFill>
                   <a:srgbClr val="3C3A39"/>
@@ -2837,6 +2858,7 @@
           <a:lstStyle xmlns:a="http://schemas.openxmlformats.org/drawingml/2006/main"/>
           <a:p xmlns:a="http://schemas.openxmlformats.org/drawingml/2006/main">
             <a:pPr>
+              <a:buNone/>
               <a:defRPr sz="2325" b="0">
                 <a:solidFill>
                   <a:srgbClr val="3C3A39"/>
@@ -2894,6 +2916,7 @@
           <a:lstStyle xmlns:a="http://schemas.openxmlformats.org/drawingml/2006/main"/>
           <a:p xmlns:a="http://schemas.openxmlformats.org/drawingml/2006/main">
             <a:pPr>
+              <a:buNone/>
               <a:defRPr sz="2325" b="0">
                 <a:solidFill>
                   <a:srgbClr val="3C3A39"/>
@@ -2951,6 +2974,7 @@
           <a:lstStyle xmlns:a="http://schemas.openxmlformats.org/drawingml/2006/main"/>
           <a:p xmlns:a="http://schemas.openxmlformats.org/drawingml/2006/main">
             <a:pPr>
+              <a:buNone/>
               <a:defRPr sz="2325" b="0">
                 <a:solidFill>
                   <a:srgbClr val="3C3A39"/>
@@ -3008,6 +3032,7 @@
           <a:lstStyle xmlns:a="http://schemas.openxmlformats.org/drawingml/2006/main"/>
           <a:p xmlns:a="http://schemas.openxmlformats.org/drawingml/2006/main">
             <a:pPr>
+              <a:buNone/>
               <a:defRPr sz="2325" b="0">
                 <a:solidFill>
                   <a:srgbClr val="3C3A39"/>
@@ -3065,6 +3090,7 @@
           <a:lstStyle xmlns:a="http://schemas.openxmlformats.org/drawingml/2006/main"/>
           <a:p xmlns:a="http://schemas.openxmlformats.org/drawingml/2006/main">
             <a:pPr>
+              <a:buNone/>
               <a:defRPr sz="1500" b="0">
                 <a:solidFill>
                   <a:srgbClr val="716E68"/>
@@ -3151,6 +3177,7 @@
           <a:lstStyle xmlns:a="http://schemas.openxmlformats.org/drawingml/2006/main"/>
           <a:p xmlns:a="http://schemas.openxmlformats.org/drawingml/2006/main">
             <a:pPr>
+              <a:buNone/>
               <a:defRPr sz="3900" b="1">
                 <a:solidFill>
                   <a:srgbClr val="3C3A39"/>
@@ -3208,6 +3235,7 @@
           <a:lstStyle xmlns:a="http://schemas.openxmlformats.org/drawingml/2006/main"/>
           <a:p xmlns:a="http://schemas.openxmlformats.org/drawingml/2006/main">
             <a:pPr>
+              <a:buNone/>
               <a:defRPr sz="2100" b="0">
                 <a:solidFill>
                   <a:srgbClr val="3C3A39"/>
@@ -3265,6 +3293,7 @@
           <a:lstStyle xmlns:a="http://schemas.openxmlformats.org/drawingml/2006/main"/>
           <a:p xmlns:a="http://schemas.openxmlformats.org/drawingml/2006/main">
             <a:pPr>
+              <a:buNone/>
               <a:defRPr sz="2100" b="0">
                 <a:solidFill>
                   <a:srgbClr val="3C3A39"/>
@@ -3322,6 +3351,7 @@
           <a:lstStyle xmlns:a="http://schemas.openxmlformats.org/drawingml/2006/main"/>
           <a:p xmlns:a="http://schemas.openxmlformats.org/drawingml/2006/main">
             <a:pPr>
+              <a:buNone/>
               <a:defRPr sz="2100" b="0">
                 <a:solidFill>
                   <a:srgbClr val="3C3A39"/>
@@ -3379,6 +3409,7 @@
           <a:lstStyle xmlns:a="http://schemas.openxmlformats.org/drawingml/2006/main"/>
           <a:p xmlns:a="http://schemas.openxmlformats.org/drawingml/2006/main">
             <a:pPr>
+              <a:buNone/>
               <a:defRPr sz="2100" b="0">
                 <a:solidFill>
                   <a:srgbClr val="3C3A39"/>
@@ -3404,14 +3435,14 @@
       </p:sp>
       <p:pic>
         <p:nvPicPr>
-          <p:cNvPr id="13" name=""/>
+          <p:cNvPr id="15" name=""/>
           <p:cNvPicPr>
             <a:picLocks xmlns:a="http://schemas.openxmlformats.org/drawingml/2006/main" noChangeAspect="1"/>
           </p:cNvPicPr>
           <p:nvPr/>
         </p:nvPicPr>
         <p:blipFill>
-          <a:blip xmlns:r="http://schemas.openxmlformats.org/officeDocument/2006/relationships" xmlns:a="http://schemas.openxmlformats.org/drawingml/2006/main" r:embed="R1444ffb89f8b4ac7"/>
+          <a:blip xmlns:r="http://schemas.openxmlformats.org/officeDocument/2006/relationships" xmlns:a="http://schemas.openxmlformats.org/drawingml/2006/main" r:embed="R8d756f87e3814684"/>
           <a:stretch xmlns:a="http://schemas.openxmlformats.org/drawingml/2006/main"/>
         </p:blipFill>
         <p:spPr>
@@ -3458,6 +3489,7 @@
           <a:lstStyle xmlns:a="http://schemas.openxmlformats.org/drawingml/2006/main"/>
           <a:p xmlns:a="http://schemas.openxmlformats.org/drawingml/2006/main">
             <a:pPr>
+              <a:buNone/>
               <a:defRPr sz="1500" b="0">
                 <a:solidFill>
                   <a:srgbClr val="716E68"/>
@@ -3544,6 +3576,7 @@
           <a:lstStyle xmlns:a="http://schemas.openxmlformats.org/drawingml/2006/main"/>
           <a:p xmlns:a="http://schemas.openxmlformats.org/drawingml/2006/main">
             <a:pPr>
+              <a:buNone/>
               <a:defRPr sz="3900" b="1">
                 <a:solidFill>
                   <a:srgbClr val="3C3A39"/>
@@ -3601,6 +3634,7 @@
           <a:lstStyle xmlns:a="http://schemas.openxmlformats.org/drawingml/2006/main"/>
           <a:p xmlns:a="http://schemas.openxmlformats.org/drawingml/2006/main">
             <a:pPr>
+              <a:buNone/>
               <a:defRPr sz="2325" b="0">
                 <a:solidFill>
                   <a:srgbClr val="3C3A39"/>
@@ -3658,6 +3692,7 @@
           <a:lstStyle xmlns:a="http://schemas.openxmlformats.org/drawingml/2006/main"/>
           <a:p xmlns:a="http://schemas.openxmlformats.org/drawingml/2006/main">
             <a:pPr>
+              <a:buNone/>
               <a:defRPr sz="2325" b="0">
                 <a:solidFill>
                   <a:srgbClr val="3C3A39"/>
@@ -3715,6 +3750,7 @@
           <a:lstStyle xmlns:a="http://schemas.openxmlformats.org/drawingml/2006/main"/>
           <a:p xmlns:a="http://schemas.openxmlformats.org/drawingml/2006/main">
             <a:pPr>
+              <a:buNone/>
               <a:defRPr sz="2325" b="0">
                 <a:solidFill>
                   <a:srgbClr val="3C3A39"/>
@@ -3772,6 +3808,7 @@
           <a:lstStyle xmlns:a="http://schemas.openxmlformats.org/drawingml/2006/main"/>
           <a:p xmlns:a="http://schemas.openxmlformats.org/drawingml/2006/main">
             <a:pPr>
+              <a:buNone/>
               <a:defRPr sz="2325" b="0">
                 <a:solidFill>
                   <a:srgbClr val="3C3A39"/>
@@ -3829,6 +3866,7 @@
           <a:lstStyle xmlns:a="http://schemas.openxmlformats.org/drawingml/2006/main"/>
           <a:p xmlns:a="http://schemas.openxmlformats.org/drawingml/2006/main">
             <a:pPr>
+              <a:buNone/>
               <a:defRPr sz="1500" b="0">
                 <a:solidFill>
                   <a:srgbClr val="716E68"/>
@@ -3915,6 +3953,7 @@
           <a:lstStyle xmlns:a="http://schemas.openxmlformats.org/drawingml/2006/main"/>
           <a:p xmlns:a="http://schemas.openxmlformats.org/drawingml/2006/main">
             <a:pPr>
+              <a:buNone/>
               <a:defRPr sz="3900" b="1">
                 <a:solidFill>
                   <a:srgbClr val="3C3A39"/>
@@ -3972,6 +4011,7 @@
           <a:lstStyle xmlns:a="http://schemas.openxmlformats.org/drawingml/2006/main"/>
           <a:p xmlns:a="http://schemas.openxmlformats.org/drawingml/2006/main">
             <a:pPr>
+              <a:buNone/>
               <a:defRPr sz="2325" b="0">
                 <a:solidFill>
                   <a:srgbClr val="3C3A39"/>
@@ -4029,6 +4069,7 @@
           <a:lstStyle xmlns:a="http://schemas.openxmlformats.org/drawingml/2006/main"/>
           <a:p xmlns:a="http://schemas.openxmlformats.org/drawingml/2006/main">
             <a:pPr>
+              <a:buNone/>
               <a:defRPr sz="2325" b="0">
                 <a:solidFill>
                   <a:srgbClr val="3C3A39"/>
@@ -4086,6 +4127,7 @@
           <a:lstStyle xmlns:a="http://schemas.openxmlformats.org/drawingml/2006/main"/>
           <a:p xmlns:a="http://schemas.openxmlformats.org/drawingml/2006/main">
             <a:pPr>
+              <a:buNone/>
               <a:defRPr sz="2325" b="0">
                 <a:solidFill>
                   <a:srgbClr val="3C3A39"/>
@@ -4143,6 +4185,7 @@
           <a:lstStyle xmlns:a="http://schemas.openxmlformats.org/drawingml/2006/main"/>
           <a:p xmlns:a="http://schemas.openxmlformats.org/drawingml/2006/main">
             <a:pPr>
+              <a:buNone/>
               <a:defRPr sz="2325" b="0">
                 <a:solidFill>
                   <a:srgbClr val="3C3A39"/>
@@ -4200,6 +4243,7 @@
           <a:lstStyle xmlns:a="http://schemas.openxmlformats.org/drawingml/2006/main"/>
           <a:p xmlns:a="http://schemas.openxmlformats.org/drawingml/2006/main">
             <a:pPr>
+              <a:buNone/>
               <a:defRPr sz="2325" b="0">
                 <a:solidFill>
                   <a:srgbClr val="3C3A39"/>
@@ -4218,7 +4262,7 @@
                 <a:ea typeface="Noto Sans Thai"/>
                 <a:cs typeface="Noto Sans Thai"/>
               </a:rPr>
-              <a:t>ยังไม่มีผล full-drive benchmark ของระบบใหม่</a:t>
+              <a:t>หลังรวม C จริง: ตรวจจำนวน ขนาด และการยกเลิก</a:t>
             </a:r>
           </a:p>
         </p:txBody>
@@ -4257,6 +4301,7 @@
           <a:lstStyle xmlns:a="http://schemas.openxmlformats.org/drawingml/2006/main"/>
           <a:p xmlns:a="http://schemas.openxmlformats.org/drawingml/2006/main">
             <a:pPr>
+              <a:buNone/>
               <a:defRPr sz="1500" b="0">
                 <a:solidFill>
                   <a:srgbClr val="716E68"/>

</xml_diff>